<commit_message>
Added slide 8 for Universal Petrol & Diesel Compatibility and updated slide 1 tagline
</commit_message>
<xml_diff>
--- a/sundar_carbon_antidote_plus_karnataka.pptx
+++ b/sundar_carbon_antidote_plus_karnataka.pptx
@@ -12,6 +12,7 @@
     <p:sldId id="260" r:id="rId11"/>
     <p:sldId id="261" r:id="rId12"/>
     <p:sldId id="262" r:id="rId13"/>
+    <p:sldId id="263" r:id="rId14"/>
   </p:sldIdLst>
   <p:sldSz cx="12188952" cy="6858000" type="screen4x3"/>
   <p:notesSz cx="6858000" cy="9144000"/>
@@ -3221,7 +3222,7 @@
               </a:defRPr>
             </a:pPr>
             <a:r>
-              <a:t>The ultimate engine rejuvenation, performance boost, and certified fuel system defense calibrated for Karnataka's road and fuel conditions.</a:t>
+              <a:t>The ultimate engine rejuvenation, performance boost, and fuel system defense calibrated for all Petrol &amp; Diesel vehicles on Karnataka's roads.</a:t>
             </a:r>
           </a:p>
         </p:txBody>
@@ -5554,6 +5555,385 @@
             </a:pPr>
             <a:r>
               <a:t>Certified to protect high-pressure fuel injectors and cylinders across Karnataka's highway and transit networks.</a:t>
+            </a:r>
+          </a:p>
+        </p:txBody>
+      </p:sp>
+    </p:spTree>
+  </p:cSld>
+  <p:clrMapOvr>
+    <a:masterClrMapping/>
+  </p:clrMapOvr>
+</p:sld>
+</file>
+
+<file path=ppt/slides/slide8.xml><?xml version="1.0" encoding="utf-8"?>
+<p:sld xmlns:a="http://schemas.openxmlformats.org/drawingml/2006/main" xmlns:p="http://schemas.openxmlformats.org/presentationml/2006/main" xmlns:r="http://schemas.openxmlformats.org/officeDocument/2006/relationships">
+  <p:cSld>
+    <p:bg>
+      <p:bgPr>
+        <a:solidFill>
+          <a:srgbClr val="07080D"/>
+        </a:solidFill>
+        <a:effectLst/>
+      </p:bgPr>
+    </p:bg>
+    <p:spTree>
+      <p:nvGrpSpPr>
+        <p:cNvPr id="1" name=""/>
+        <p:cNvGrpSpPr/>
+        <p:nvPr/>
+      </p:nvGrpSpPr>
+      <p:grpSpPr/>
+      <p:sp>
+        <p:nvSpPr>
+          <p:cNvPr id="2" name="TextBox 1"/>
+          <p:cNvSpPr txBox="1"/>
+          <p:nvPr/>
+        </p:nvSpPr>
+        <p:spPr>
+          <a:xfrm>
+            <a:off x="731520" y="457200"/>
+            <a:ext cx="9144000" cy="365760"/>
+          </a:xfrm>
+          <a:prstGeom prst="rect">
+            <a:avLst/>
+          </a:prstGeom>
+          <a:noFill/>
+        </p:spPr>
+        <p:txBody>
+          <a:bodyPr wrap="square">
+            <a:spAutoFit/>
+          </a:bodyPr>
+          <a:lstStyle/>
+          <a:p>
+            <a:pPr>
+              <a:defRPr sz="1100" b="1">
+                <a:solidFill>
+                  <a:srgbClr val="00F0FF"/>
+                </a:solidFill>
+                <a:latin typeface="Outfit"/>
+              </a:defRPr>
+            </a:pPr>
+            <a:r>
+              <a:t>COMPATIBILITY</a:t>
+            </a:r>
+          </a:p>
+        </p:txBody>
+      </p:sp>
+      <p:sp>
+        <p:nvSpPr>
+          <p:cNvPr id="3" name="TextBox 2"/>
+          <p:cNvSpPr txBox="1"/>
+          <p:nvPr/>
+        </p:nvSpPr>
+        <p:spPr>
+          <a:xfrm>
+            <a:off x="731520" y="731520"/>
+            <a:ext cx="10515600" cy="731520"/>
+          </a:xfrm>
+          <a:prstGeom prst="rect">
+            <a:avLst/>
+          </a:prstGeom>
+          <a:noFill/>
+        </p:spPr>
+        <p:txBody>
+          <a:bodyPr wrap="square">
+            <a:spAutoFit/>
+          </a:bodyPr>
+          <a:lstStyle/>
+          <a:p>
+            <a:pPr>
+              <a:defRPr sz="3600" b="1">
+                <a:solidFill>
+                  <a:srgbClr val="FFFFFF"/>
+                </a:solidFill>
+                <a:latin typeface="Outfit"/>
+              </a:defRPr>
+            </a:pPr>
+            <a:r>
+              <a:t>Universal Fuel Adaptability</a:t>
+            </a:r>
+          </a:p>
+        </p:txBody>
+      </p:sp>
+      <p:pic>
+        <p:nvPicPr>
+          <p:cNvPr id="4" name="Picture 3" descr="logo.jpg"/>
+          <p:cNvPicPr>
+            <a:picLocks noChangeAspect="1"/>
+          </p:cNvPicPr>
+          <p:nvPr/>
+        </p:nvPicPr>
+        <p:blipFill>
+          <a:blip r:embed="rId2"/>
+          <a:stretch>
+            <a:fillRect/>
+          </a:stretch>
+        </p:blipFill>
+        <p:spPr>
+          <a:xfrm>
+            <a:off x="10058400" y="365760"/>
+            <a:ext cx="1463040" cy="594360"/>
+          </a:xfrm>
+          <a:prstGeom prst="rect">
+            <a:avLst/>
+          </a:prstGeom>
+        </p:spPr>
+      </p:pic>
+      <p:sp>
+        <p:nvSpPr>
+          <p:cNvPr id="5" name="TextBox 4"/>
+          <p:cNvSpPr txBox="1"/>
+          <p:nvPr/>
+        </p:nvSpPr>
+        <p:spPr>
+          <a:xfrm>
+            <a:off x="731520" y="1645920"/>
+            <a:ext cx="5486400" cy="4572000"/>
+          </a:xfrm>
+          <a:prstGeom prst="rect">
+            <a:avLst/>
+          </a:prstGeom>
+          <a:noFill/>
+        </p:spPr>
+        <p:txBody>
+          <a:bodyPr wrap="square">
+            <a:spAutoFit/>
+          </a:bodyPr>
+          <a:lstStyle/>
+          <a:p>
+            <a:pPr>
+              <a:spcAft>
+                <a:spcPts val="2500"/>
+              </a:spcAft>
+              <a:defRPr sz="1500">
+                <a:solidFill>
+                  <a:srgbClr val="9FA4B0"/>
+                </a:solidFill>
+                <a:latin typeface="Inter"/>
+              </a:defRPr>
+            </a:pPr>
+            <a:r>
+              <a:t>Formulated to optimize all standard combustible fuel engine configurations:</a:t>
+            </a:r>
+          </a:p>
+          <a:p>
+            <a:pPr>
+              <a:spcAft>
+                <a:spcPts val="1400"/>
+              </a:spcAft>
+              <a:defRPr sz="1300">
+                <a:solidFill>
+                  <a:srgbClr val="00F0FF"/>
+                </a:solidFill>
+                <a:latin typeface="Inter"/>
+              </a:defRPr>
+            </a:pPr>
+            <a:r>
+              <a:t>• </a:t>
+            </a:r>
+            <a:r>
+              <a:rPr b="1">
+                <a:solidFill>
+                  <a:srgbClr val="FFFFFF"/>
+                </a:solidFill>
+              </a:rPr>
+              <a:t>Petrol Engines (Ethanol Defense):</a:t>
+            </a:r>
+            <a:r>
+              <a:rPr>
+                <a:solidFill>
+                  <a:srgbClr val="9FA4B0"/>
+                </a:solidFill>
+              </a:rPr>
+              <a:t> Actively guards delicate BS4 &amp; BS6 injectors from corrosive sugarcane-blended E20 fuel deposits.</a:t>
+            </a:r>
+          </a:p>
+          <a:p>
+            <a:pPr>
+              <a:spcAft>
+                <a:spcPts val="1400"/>
+              </a:spcAft>
+              <a:defRPr sz="1300">
+                <a:solidFill>
+                  <a:srgbClr val="00F0FF"/>
+                </a:solidFill>
+                <a:latin typeface="Inter"/>
+              </a:defRPr>
+            </a:pPr>
+            <a:r>
+              <a:t>• </a:t>
+            </a:r>
+            <a:r>
+              <a:rPr b="1">
+                <a:solidFill>
+                  <a:srgbClr val="FFFFFF"/>
+                </a:solidFill>
+              </a:rPr>
+              <a:t>Diesel Engines (Heavy Duty):</a:t>
+            </a:r>
+            <a:r>
+              <a:rPr>
+                <a:solidFill>
+                  <a:srgbClr val="9FA4B0"/>
+                </a:solidFill>
+              </a:rPr>
+              <a:t> Prevents cylinder scaling, exhaust soot buildup, and injectors carbonization under heavy-duty cargo demands.</a:t>
+            </a:r>
+          </a:p>
+          <a:p>
+            <a:pPr>
+              <a:spcAft>
+                <a:spcPts val="1400"/>
+              </a:spcAft>
+              <a:defRPr sz="1300">
+                <a:solidFill>
+                  <a:srgbClr val="00F0FF"/>
+                </a:solidFill>
+                <a:latin typeface="Inter"/>
+              </a:defRPr>
+            </a:pPr>
+            <a:r>
+              <a:t>• </a:t>
+            </a:r>
+            <a:r>
+              <a:rPr b="1">
+                <a:solidFill>
+                  <a:srgbClr val="FFFFFF"/>
+                </a:solidFill>
+              </a:rPr>
+              <a:t>Multi-Fuel Performance:</a:t>
+            </a:r>
+            <a:r>
+              <a:rPr>
+                <a:solidFill>
+                  <a:srgbClr val="9FA4B0"/>
+                </a:solidFill>
+              </a:rPr>
+              <a:t> Works identically on petrol-powered commuter vehicles and diesel-powered cargo fleets, requiring no formula alterations.</a:t>
+            </a:r>
+          </a:p>
+        </p:txBody>
+      </p:sp>
+      <p:sp>
+        <p:nvSpPr>
+          <p:cNvPr id="6" name="Rounded Rectangle 5"/>
+          <p:cNvSpPr/>
+          <p:nvPr/>
+        </p:nvSpPr>
+        <p:spPr>
+          <a:xfrm>
+            <a:off x="6858000" y="1645920"/>
+            <a:ext cx="4572000" cy="4114800"/>
+          </a:xfrm>
+          <a:prstGeom prst="roundRect">
+            <a:avLst/>
+          </a:prstGeom>
+          <a:solidFill>
+            <a:srgbClr val="181A25"/>
+          </a:solidFill>
+          <a:ln w="19050">
+            <a:solidFill>
+              <a:srgbClr val="00F0FF"/>
+            </a:solidFill>
+          </a:ln>
+        </p:spPr>
+        <p:style>
+          <a:lnRef idx="1">
+            <a:schemeClr val="accent1"/>
+          </a:lnRef>
+          <a:fillRef idx="3">
+            <a:schemeClr val="accent1"/>
+          </a:fillRef>
+          <a:effectRef idx="2">
+            <a:schemeClr val="accent1"/>
+          </a:effectRef>
+          <a:fontRef idx="minor">
+            <a:schemeClr val="lt1"/>
+          </a:fontRef>
+        </p:style>
+        <p:txBody>
+          <a:bodyPr rtlCol="0" anchor="ctr" wrap="square" lIns="365760" rIns="365760" tIns="548640"/>
+          <a:lstStyle/>
+          <a:p>
+            <a:pPr algn="ctr">
+              <a:spcAft>
+                <a:spcPts val="1500"/>
+              </a:spcAft>
+              <a:defRPr b="1" sz="1800">
+                <a:solidFill>
+                  <a:srgbClr val="00F0FF"/>
+                </a:solidFill>
+                <a:latin typeface="Outfit"/>
+              </a:defRPr>
+            </a:pPr>
+            <a:r>
+              <a:t>PETROL &amp; DIESEL DUAL ACTION</a:t>
+            </a:r>
+          </a:p>
+          <a:p>
+            <a:pPr>
+              <a:spcAft>
+                <a:spcPts val="1200"/>
+              </a:spcAft>
+              <a:defRPr sz="1300">
+                <a:solidFill>
+                  <a:srgbClr val="FFFFFF"/>
+                </a:solidFill>
+                <a:latin typeface="Inter"/>
+              </a:defRPr>
+            </a:pPr>
+            <a:r>
+              <a:t>⚡ Two-Wheelers &amp; Scooters (Petrol)</a:t>
+            </a:r>
+          </a:p>
+          <a:p>
+            <a:pPr>
+              <a:spcAft>
+                <a:spcPts val="1200"/>
+              </a:spcAft>
+              <a:defRPr sz="1300">
+                <a:solidFill>
+                  <a:srgbClr val="FFFFFF"/>
+                </a:solidFill>
+                <a:latin typeface="Inter"/>
+              </a:defRPr>
+            </a:pPr>
+            <a:r>
+              <a:t>⚡ Passenger Cars, Hatchbacks &amp; Sedans</a:t>
+            </a:r>
+          </a:p>
+          <a:p>
+            <a:pPr>
+              <a:spcAft>
+                <a:spcPts val="1200"/>
+              </a:spcAft>
+              <a:defRPr sz="1300">
+                <a:solidFill>
+                  <a:srgbClr val="FFFFFF"/>
+                </a:solidFill>
+                <a:latin typeface="Inter"/>
+              </a:defRPr>
+            </a:pPr>
+            <a:r>
+              <a:t>⚡ Commercial Transit Buses &amp; Coaches (Diesel)</a:t>
+            </a:r>
+          </a:p>
+          <a:p>
+            <a:pPr>
+              <a:spcAft>
+                <a:spcPts val="1200"/>
+              </a:spcAft>
+              <a:defRPr sz="1300">
+                <a:solidFill>
+                  <a:srgbClr val="FFFFFF"/>
+                </a:solidFill>
+                <a:latin typeface="Inter"/>
+              </a:defRPr>
+            </a:pPr>
+            <a:r>
+              <a:t>⚡ Heavy Logistics Trucks &amp; Cargo Fleets</a:t>
             </a:r>
           </a:p>
         </p:txBody>

</xml_diff>